<commit_message>
fix: Synchronize Prisma schemas across workspaces
</commit_message>
<xml_diff>
--- a/SUPER ADMIN ROLE - DEAN ROLE.pptx
+++ b/SUPER ADMIN ROLE - DEAN ROLE.pptx
@@ -4013,6 +4013,50 @@
           </a:prstGeom>
         </p:spPr>
       </p:pic>
+      <p:sp>
+        <p:nvSpPr>
+          <p:cNvPr id="7" name="TextBox 6">
+            <a:extLst>
+              <a:ext uri="{FF2B5EF4-FFF2-40B4-BE49-F238E27FC236}">
+                <a16:creationId xmlns:a16="http://schemas.microsoft.com/office/drawing/2014/main" id="{26810F9D-D1E7-F720-1327-3AA66B99283A}"/>
+              </a:ext>
+            </a:extLst>
+          </p:cNvPr>
+          <p:cNvSpPr txBox="1"/>
+          <p:nvPr/>
+        </p:nvSpPr>
+        <p:spPr>
+          <a:xfrm>
+            <a:off x="1941689" y="4312356"/>
+            <a:ext cx="6163733" cy="923330"/>
+          </a:xfrm>
+          <a:prstGeom prst="rect">
+            <a:avLst/>
+          </a:prstGeom>
+          <a:noFill/>
+        </p:spPr>
+        <p:txBody>
+          <a:bodyPr wrap="square" rtlCol="0">
+            <a:spAutoFit/>
+          </a:bodyPr>
+          <a:lstStyle/>
+          <a:p>
+            <a:r>
+              <a:rPr lang="en-US" b="1" dirty="0">
+                <a:solidFill>
+                  <a:srgbClr val="FF0000"/>
+                </a:solidFill>
+              </a:rPr>
+              <a:t>This is Dean (Super Admin) Access Dashboard and Dean has complete access of all Departments, Faculty Members, Courses and Students.</a:t>
+            </a:r>
+            <a:r>
+              <a:rPr lang="en-US" dirty="0"/>
+              <a:t> </a:t>
+            </a:r>
+            <a:endParaRPr lang="en-PK" dirty="0"/>
+          </a:p>
+        </p:txBody>
+      </p:sp>
     </p:spTree>
     <p:extLst>
       <p:ext uri="{BB962C8B-B14F-4D97-AF65-F5344CB8AC3E}">
@@ -4151,6 +4195,36 @@
           </a:p>
         </p:txBody>
       </p:sp>
+      <p:pic>
+        <p:nvPicPr>
+          <p:cNvPr id="6" name="Picture 5">
+            <a:extLst>
+              <a:ext uri="{FF2B5EF4-FFF2-40B4-BE49-F238E27FC236}">
+                <a16:creationId xmlns:a16="http://schemas.microsoft.com/office/drawing/2014/main" id="{292FE8D5-3363-053D-1532-28E35E053D8F}"/>
+              </a:ext>
+            </a:extLst>
+          </p:cNvPr>
+          <p:cNvPicPr>
+            <a:picLocks noChangeAspect="1"/>
+          </p:cNvPicPr>
+          <p:nvPr/>
+        </p:nvPicPr>
+        <p:blipFill>
+          <a:blip r:embed="rId2"/>
+          <a:stretch>
+            <a:fillRect/>
+          </a:stretch>
+        </p:blipFill>
+        <p:spPr>
+          <a:xfrm>
+            <a:off x="0" y="0"/>
+            <a:ext cx="12192000" cy="6357546"/>
+          </a:xfrm>
+          <a:prstGeom prst="rect">
+            <a:avLst/>
+          </a:prstGeom>
+        </p:spPr>
+      </p:pic>
     </p:spTree>
     <p:extLst>
       <p:ext uri="{BB962C8B-B14F-4D97-AF65-F5344CB8AC3E}">

</xml_diff>

<commit_message>
fix: Improved material form visibility logic and added YouTube link support
</commit_message>
<xml_diff>
--- a/SUPER ADMIN ROLE - DEAN ROLE.pptx
+++ b/SUPER ADMIN ROLE - DEAN ROLE.pptx
@@ -4225,6 +4225,50 @@
           </a:prstGeom>
         </p:spPr>
       </p:pic>
+      <p:sp>
+        <p:nvSpPr>
+          <p:cNvPr id="7" name="TextBox 6">
+            <a:extLst>
+              <a:ext uri="{FF2B5EF4-FFF2-40B4-BE49-F238E27FC236}">
+                <a16:creationId xmlns:a16="http://schemas.microsoft.com/office/drawing/2014/main" id="{18D940F8-F89E-7673-A2D7-0815E7A9D059}"/>
+              </a:ext>
+            </a:extLst>
+          </p:cNvPr>
+          <p:cNvSpPr txBox="1"/>
+          <p:nvPr/>
+        </p:nvSpPr>
+        <p:spPr>
+          <a:xfrm>
+            <a:off x="8771466" y="4001294"/>
+            <a:ext cx="3183467" cy="646331"/>
+          </a:xfrm>
+          <a:prstGeom prst="rect">
+            <a:avLst/>
+          </a:prstGeom>
+          <a:noFill/>
+        </p:spPr>
+        <p:txBody>
+          <a:bodyPr wrap="square" rtlCol="0">
+            <a:spAutoFit/>
+          </a:bodyPr>
+          <a:lstStyle/>
+          <a:p>
+            <a:r>
+              <a:rPr lang="en-US" b="1" dirty="0">
+                <a:solidFill>
+                  <a:srgbClr val="FF0000"/>
+                </a:solidFill>
+              </a:rPr>
+              <a:t>Dean can Change HOD of Any department by click Edit Button</a:t>
+            </a:r>
+            <a:endParaRPr lang="en-PK" b="1" dirty="0">
+              <a:solidFill>
+                <a:srgbClr val="FF0000"/>
+              </a:solidFill>
+            </a:endParaRPr>
+          </a:p>
+        </p:txBody>
+      </p:sp>
     </p:spTree>
     <p:extLst>
       <p:ext uri="{BB962C8B-B14F-4D97-AF65-F5344CB8AC3E}">

</xml_diff>

<commit_message>
fix: implemented Secure Backend Proxy for material downloads to guarantee zero 401 errors
</commit_message>
<xml_diff>
--- a/SUPER ADMIN ROLE - DEAN ROLE.pptx
+++ b/SUPER ADMIN ROLE - DEAN ROLE.pptx
@@ -7195,7 +7195,19 @@
           <a:bodyPr/>
           <a:lstStyle/>
           <a:p>
-            <a:endParaRPr lang="en-PK"/>
+            <a:r>
+              <a:rPr lang="en-US" b="1" dirty="0">
+                <a:solidFill>
+                  <a:srgbClr val="FF0000"/>
+                </a:solidFill>
+              </a:rPr>
+              <a:t>DEAN OFFICE (SUB-ADMIN) ACCESS</a:t>
+            </a:r>
+            <a:endParaRPr lang="en-PK" b="1" dirty="0">
+              <a:solidFill>
+                <a:srgbClr val="FF0000"/>
+              </a:solidFill>
+            </a:endParaRPr>
           </a:p>
         </p:txBody>
       </p:sp>
@@ -7220,7 +7232,56 @@
           <a:bodyPr/>
           <a:lstStyle/>
           <a:p>
-            <a:endParaRPr lang="en-PK"/>
+            <a:r>
+              <a:rPr lang="en-US" dirty="0"/>
+              <a:t>Dean Office Access Credentials are as follows:</a:t>
+            </a:r>
+          </a:p>
+          <a:p>
+            <a:pPr marL="0" indent="0">
+              <a:buNone/>
+            </a:pPr>
+            <a:r>
+              <a:rPr lang="en-US" dirty="0"/>
+              <a:t>Email: office@uok.edu.pk </a:t>
+            </a:r>
+          </a:p>
+          <a:p>
+            <a:pPr marL="0" indent="0">
+              <a:buNone/>
+            </a:pPr>
+            <a:r>
+              <a:rPr lang="en-US" dirty="0"/>
+              <a:t>Password: 123456</a:t>
+            </a:r>
+          </a:p>
+          <a:p>
+            <a:pPr marL="0" indent="0">
+              <a:buNone/>
+            </a:pPr>
+            <a:endParaRPr lang="en-US" dirty="0"/>
+          </a:p>
+          <a:p>
+            <a:pPr marL="0" indent="0">
+              <a:buNone/>
+            </a:pPr>
+            <a:r>
+              <a:rPr lang="en-US" dirty="0"/>
+              <a:t>Dean Office able to:</a:t>
+            </a:r>
+          </a:p>
+          <a:p>
+            <a:r>
+              <a:rPr lang="en-US" dirty="0"/>
+              <a:t>APPROVE Student’s Account.</a:t>
+            </a:r>
+          </a:p>
+          <a:p>
+            <a:r>
+              <a:rPr lang="en-US" dirty="0"/>
+              <a:t>Add Time Table, Exams Sheet, Results and also send notification</a:t>
+            </a:r>
+            <a:endParaRPr lang="en-PK" dirty="0"/>
           </a:p>
         </p:txBody>
       </p:sp>

</xml_diff>

<commit_message>
fix: switched PDF workflow to mandatory Google Drive links for 100% reliable document delivery
</commit_message>
<xml_diff>
--- a/SUPER ADMIN ROLE - DEAN ROLE.pptx
+++ b/SUPER ADMIN ROLE - DEAN ROLE.pptx
@@ -7394,7 +7394,11 @@
           <a:bodyPr/>
           <a:lstStyle/>
           <a:p>
-            <a:endParaRPr lang="en-PK"/>
+            <a:r>
+              <a:rPr lang="en-US" dirty="0"/>
+              <a:t>Other Accounts Access</a:t>
+            </a:r>
+            <a:endParaRPr lang="en-PK" dirty="0"/>
           </a:p>
         </p:txBody>
       </p:sp>
@@ -7419,6 +7423,30 @@
           <a:bodyPr/>
           <a:lstStyle/>
           <a:p>
+            <a:r>
+              <a:rPr lang="en-US" dirty="0"/>
+              <a:t>HODs Account</a:t>
+            </a:r>
+          </a:p>
+          <a:p>
+            <a:r>
+              <a:rPr lang="en-US" dirty="0"/>
+              <a:t>Faculty (Teachers)</a:t>
+            </a:r>
+          </a:p>
+          <a:p>
+            <a:r>
+              <a:rPr lang="en-US" dirty="0"/>
+              <a:t>Students: All 5 Years, </a:t>
+            </a:r>
+            <a:r>
+              <a:rPr lang="en-US" dirty="0" err="1"/>
+              <a:t>M.Phil</a:t>
+            </a:r>
+            <a:r>
+              <a:rPr lang="en-US"/>
+              <a:t> and PhD Students </a:t>
+            </a:r>
             <a:endParaRPr lang="en-PK"/>
           </a:p>
         </p:txBody>

</xml_diff>